<commit_message>
docs: Maha Friday deck, crib sheet, and paper-ready results section
Plain-language predictor names per Maha's feedback; every slide footer
cites its generating file; crib sheet answers each advisor question in
first person with leak-safe numbers.

Co-authored-by: Cursor <cursoragent@cursor.com>
</commit_message>
<xml_diff>
--- a/Frozen-BN-Narrative-Evidence-2026-07-20/presentations_FrozenBN/jesse_jul28_update.pptx
+++ b/Frozen-BN-Narrative-Evidence-2026-07-20/presentations_FrozenBN/jesse_jul28_update.pptx
@@ -2267,7 +2267,7 @@
           <a:lstStyle/>
           <a:p>
             <a:r>
-              <a:t>Never used in network construction.</a:t>
+              <a:t>Never used in network construction. Leak-safe: outcome phrases redacted before embedding; stated-severity readout OFF (supersedes pre-audit 93%/81%). Source: outputs/heldout_significance.md</a:t>
             </a:r>
           </a:p>
         </p:txBody>
@@ -2477,7 +2477,7 @@
           <a:lstStyle/>
           <a:p>
             <a:r>
-              <a:t>Never beat baseline; struct-first hurts severity.</a:t>
+              <a:t>Never beat baseline; struct-first hurts severity. Severity rows were run PRE-redaction (baseline 92.9%/81.4%); paired comparison still valid — every variant saw the same text.</a:t>
             </a:r>
           </a:p>
         </p:txBody>
@@ -11580,7 +11580,7 @@
           <a:p>
             <a:pPr/>
             <a:r>
-              <a:t>Proof: reproduce Zhang + 296 held-out accidents (~93% injury)</a:t>
+              <a:t>Proof: reproduce Zhang + 296 held-out accidents (~91% injury, leak-safe)</a:t>
             </a:r>
           </a:p>
           <a:p>
@@ -11664,33 +11664,9 @@
           </a:p>
         </p:txBody>
       </p:sp>
-      <p:pic>
-        <p:nvPicPr>
-          <p:cNvPr id="4" name="Picture 3" descr="narrative_to_bn_architecture.png"/>
-          <p:cNvPicPr>
-            <a:picLocks noChangeAspect="1"/>
-          </p:cNvPicPr>
-          <p:nvPr/>
-        </p:nvPicPr>
-        <p:blipFill>
-          <a:blip r:embed="rId3"/>
-          <a:stretch>
-            <a:fillRect/>
-          </a:stretch>
-        </p:blipFill>
-        <p:spPr>
-          <a:xfrm>
-            <a:off x="6400800" y="1417320"/>
-            <a:ext cx="4842014" cy="3291840"/>
-          </a:xfrm>
-          <a:prstGeom prst="rect">
-            <a:avLst/>
-          </a:prstGeom>
-        </p:spPr>
-      </p:pic>
       <p:sp>
         <p:nvSpPr>
-          <p:cNvPr id="5" name="TextBox 4"/>
+          <p:cNvPr id="4" name="TextBox 3"/>
           <p:cNvSpPr txBox="1"/>
           <p:nvPr/>
         </p:nvSpPr>
@@ -12315,9 +12291,9 @@
                 <a:tableStyleId>{5C22544A-7EE6-4342-B048-85BDC9FD1C3A}</a:tableStyleId>
               </a:tblPr>
               <a:tblGrid>
-                <a:gridCol w="4572000"/>
-                <a:gridCol w="2286000"/>
-                <a:gridCol w="2286000"/>
+                <a:gridCol w="5486400"/>
+                <a:gridCol w="1828800"/>
+                <a:gridCol w="1828800"/>
               </a:tblGrid>
               <a:tr h="457200">
                 <a:tc>
@@ -12401,7 +12377,7 @@
                             <a:srgbClr val="000000"/>
                           </a:solidFill>
                         </a:rPr>
-                        <a:t>58%</a:t>
+                        <a:t>58.4%</a:t>
                       </a:r>
                     </a:p>
                   </a:txBody>
@@ -12418,7 +12394,7 @@
                             <a:srgbClr val="000000"/>
                           </a:solidFill>
                         </a:rPr>
-                        <a:t>43%</a:t>
+                        <a:t>42.6%</a:t>
                       </a:r>
                     </a:p>
                   </a:txBody>
@@ -12437,7 +12413,7 @@
                             <a:srgbClr val="000000"/>
                           </a:solidFill>
                         </a:rPr>
-                        <a:t>Full narrative → BN</a:t>
+                        <a:t>Event evidence → frozen BN</a:t>
                       </a:r>
                     </a:p>
                   </a:txBody>
@@ -12454,7 +12430,7 @@
                             <a:srgbClr val="000000"/>
                           </a:solidFill>
                         </a:rPr>
-                        <a:t>89%</a:t>
+                        <a:t>89.9%</a:t>
                       </a:r>
                     </a:p>
                   </a:txBody>
@@ -12471,7 +12447,7 @@
                             <a:srgbClr val="000000"/>
                           </a:solidFill>
                         </a:rPr>
-                        <a:t>64%</a:t>
+                        <a:t>55.7%</a:t>
                       </a:r>
                     </a:p>
                   </a:txBody>
@@ -12490,7 +12466,7 @@
                             <a:srgbClr val="000000"/>
                           </a:solidFill>
                         </a:rPr>
-                        <a:t>Best readout (narr-sev)</a:t>
+                        <a:t>k-NN severity via frozen BN (primary)</a:t>
                       </a:r>
                     </a:p>
                   </a:txBody>
@@ -12507,7 +12483,7 @@
                             <a:srgbClr val="000000"/>
                           </a:solidFill>
                         </a:rPr>
-                        <a:t>93%</a:t>
+                        <a:t>90.9%</a:t>
                       </a:r>
                     </a:p>
                   </a:txBody>
@@ -12524,7 +12500,7 @@
                             <a:srgbClr val="000000"/>
                           </a:solidFill>
                         </a:rPr>
-                        <a:t>81%</a:t>
+                        <a:t>77.4%</a:t>
                       </a:r>
                     </a:p>
                   </a:txBody>
@@ -12543,7 +12519,7 @@
                             <a:srgbClr val="000000"/>
                           </a:solidFill>
                         </a:rPr>
-                        <a:t>Supervised LR baseline</a:t>
+                        <a:t>Supervised LR (parsed features)</a:t>
                       </a:r>
                     </a:p>
                   </a:txBody>
@@ -12560,7 +12536,7 @@
                             <a:srgbClr val="000000"/>
                           </a:solidFill>
                         </a:rPr>
-                        <a:t>88%</a:t>
+                        <a:t>87.8%</a:t>
                       </a:r>
                     </a:p>
                   </a:txBody>
@@ -12577,7 +12553,7 @@
                             <a:srgbClr val="000000"/>
                           </a:solidFill>
                         </a:rPr>
-                        <a:t>65%</a:t>
+                        <a:t>64.2%</a:t>
                       </a:r>
                     </a:p>
                   </a:txBody>
@@ -12596,7 +12572,7 @@
                             <a:srgbClr val="000000"/>
                           </a:solidFill>
                         </a:rPr>
-                        <a:t>LLM-only front door</a:t>
+                        <a:t>Supervised LR (narrative embedding)</a:t>
                       </a:r>
                     </a:p>
                   </a:txBody>
@@ -12613,7 +12589,7 @@
                             <a:srgbClr val="000000"/>
                           </a:solidFill>
                         </a:rPr>
-                        <a:t>69%</a:t>
+                        <a:t>91.6%</a:t>
                       </a:r>
                     </a:p>
                   </a:txBody>
@@ -12630,7 +12606,7 @@
                             <a:srgbClr val="000000"/>
                           </a:solidFill>
                         </a:rPr>
-                        <a:t>58%</a:t>
+                        <a:t>74.0%</a:t>
                       </a:r>
                     </a:p>
                   </a:txBody>
@@ -12665,7 +12641,7 @@
           <a:p>
             <a:r>
               <a:rPr sz="1600" b="1"/>
-              <a:t>Narratives early; coded labels late — ~93% injury on unseen cases.</a:t>
+              <a:t>Narratives early; coded labels late — ~91% injury on unseen cases, zero trained parameters, leak-audited.</a:t>
             </a:r>
           </a:p>
         </p:txBody>

</xml_diff>